<commit_message>
docs: URL de produccion, repositorio y MySQL en README, despliegue y presentacion
Co-Authored-By: Claude Opus 5 <noreply@anthropic.com>
</commit_message>
<xml_diff>
--- a/docs/presentacion/Generacion-Solar-Guatemala.pptx
+++ b/docs/presentacion/Generacion-Solar-Guatemala.pptx
@@ -4231,7 +4231,7 @@
                 <a:ea typeface="Calibri" pitchFamily="34" charset="-122"/>
                 <a:cs typeface="Calibri" pitchFamily="34" charset="-120"/>
               </a:rPr>
-              <a:t>https://</a:t>
+              <a:t>generacion-solar-production-gtqero.laravel.cloud</a:t>
             </a:r>
             <a:endParaRPr lang="en-US" sz="1100" dirty="0"/>
           </a:p>
@@ -4309,7 +4309,7 @@
                 <a:ea typeface="Calibri" pitchFamily="34" charset="-122"/>
                 <a:cs typeface="Calibri" pitchFamily="34" charset="-120"/>
               </a:rPr>
-              <a:t>github.com/</a:t>
+              <a:t>github.com/Nehemiasp/generacion-solar</a:t>
             </a:r>
             <a:endParaRPr lang="en-US" sz="1100" dirty="0"/>
           </a:p>
@@ -4387,7 +4387,7 @@
                 <a:ea typeface="Calibri" pitchFamily="34" charset="-122"/>
                 <a:cs typeface="Calibri" pitchFamily="34" charset="-120"/>
               </a:rPr>
-              <a:t>/docs/api</a:t>
+              <a:t>generacion-solar-production-gtqero.laravel.cloud/docs/api</a:t>
             </a:r>
             <a:endParaRPr lang="en-US" sz="1100" dirty="0"/>
           </a:p>

</xml_diff>

<commit_message>
docs: diapositiva 2 con el umbral de alerta en lugar del tiempo de desarrollo
Co-Authored-By: Claude Opus 5 <noreply@anthropic.com>
</commit_message>
<xml_diff>
--- a/docs/presentacion/Generacion-Solar-Guatemala.pptx
+++ b/docs/presentacion/Generacion-Solar-Guatemala.pptx
@@ -4851,7 +4851,7 @@
                 <a:ea typeface="Arial" pitchFamily="34" charset="-122"/>
                 <a:cs typeface="Arial" pitchFamily="34" charset="-120"/>
               </a:rPr>
-              <a:t>1</a:t>
+              <a:t>80 %</a:t>
             </a:r>
             <a:endParaRPr lang="en-US" sz="3400" dirty="0"/>
           </a:p>
@@ -4890,7 +4890,7 @@
                 <a:ea typeface="Calibri" pitchFamily="34" charset="-122"/>
                 <a:cs typeface="Calibri" pitchFamily="34" charset="-120"/>
               </a:rPr>
-              <a:t>día</a:t>
+              <a:t>umbral de alerta</a:t>
             </a:r>
             <a:endParaRPr lang="en-US" sz="1200" dirty="0"/>
           </a:p>
@@ -4932,7 +4932,7 @@
                 <a:ea typeface="Calibri" pitchFamily="34" charset="-122"/>
                 <a:cs typeface="Calibri" pitchFamily="34" charset="-120"/>
               </a:rPr>
-              <a:t>De la base de datos vacía a la aplicación desplegada</a:t>
+              <a:t>Generación real igual o menor a ese porcentaje de la esperada</a:t>
             </a:r>
             <a:endParaRPr lang="en-US" sz="1050" dirty="0"/>
           </a:p>
@@ -5150,7 +5150,7 @@
                 <a:ea typeface="Calibri" pitchFamily="34" charset="-122"/>
                 <a:cs typeface="Calibri" pitchFamily="34" charset="-120"/>
               </a:rPr>
-              <a:t>Alerta cuando la generación real cae al 80% de la esperada o menos</a:t>
+              <a:t>Alerta automática al cruzar el umbral, sin intervención del operador</a:t>
             </a:r>
             <a:endParaRPr lang="en-US" sz="1200" dirty="0"/>
           </a:p>

</xml_diff>

<commit_message>
docs: integrante y roles, prompts redactados, portada de la presentacion
Co-Authored-By: Claude Opus 5 <noreply@anthropic.com>
</commit_message>
<xml_diff>
--- a/docs/presentacion/Generacion-Solar-Guatemala.pptx
+++ b/docs/presentacion/Generacion-Solar-Guatemala.pptx
@@ -2843,7 +2843,7 @@
                 <a:ea typeface="Calibri" pitchFamily="34" charset="-122"/>
                 <a:cs typeface="Calibri" pitchFamily="34" charset="-120"/>
               </a:rPr>
-              <a:t>Equipo</a:t>
+              <a:t>Presenta</a:t>
             </a:r>
             <a:endParaRPr lang="en-US" sz="1000" dirty="0"/>
           </a:p>
@@ -2885,7 +2885,7 @@
                 <a:ea typeface="Calibri" pitchFamily="34" charset="-122"/>
                 <a:cs typeface="Calibri" pitchFamily="34" charset="-120"/>
               </a:rPr>
-              <a:t>Integrante 1</a:t>
+              <a:t>Nehemías Pérez Palma</a:t>
             </a:r>
             <a:endParaRPr lang="en-US" sz="1200" dirty="0"/>
           </a:p>
@@ -2905,7 +2905,7 @@
                 <a:ea typeface="Calibri" pitchFamily="34" charset="-122"/>
                 <a:cs typeface="Calibri" pitchFamily="34" charset="-120"/>
               </a:rPr>
-              <a:t>Integrante 2</a:t>
+              <a:t>Carné 0909-26-9887</a:t>
             </a:r>
             <a:endParaRPr lang="en-US" sz="1200" dirty="0"/>
           </a:p>

</xml_diff>